<commit_message>
feat: implement PPT automation module, user profile management, and password reset functionality
</commit_message>
<xml_diff>
--- a/entrans-hr-hub-backend/myproject/media/Final_Anniversary_Presentation.pptx
+++ b/entrans-hr-hub-backend/myproject/media/Final_Anniversary_Presentation.pptx
@@ -15,6 +15,11 @@
     <p:sldId id="265" r:id="rId20"/>
     <p:sldId id="266" r:id="rId21"/>
     <p:sldId id="267" r:id="rId22"/>
+    <p:sldId id="268" r:id="rId23"/>
+    <p:sldId id="269" r:id="rId24"/>
+    <p:sldId id="270" r:id="rId25"/>
+    <p:sldId id="271" r:id="rId26"/>
+    <p:sldId id="272" r:id="rId27"/>
   </p:sldIdLst>
   <p:sldSz cx="9144000" cy="5143500" type="screen16x9"/>
   <p:notesSz cx="6858000" cy="9144000"/>
@@ -10023,7 +10028,7 @@
               </a:defRPr>
             </a:pPr>
             <a:r>
-              <a:t>joe</a:t>
+              <a:t>Joe Dharsic</a:t>
             </a:r>
           </a:p>
         </p:txBody>
@@ -10075,7 +10080,15 @@
               </a:defRPr>
             </a:pPr>
             <a:r>
-              <a:t>Congratulations on your first work anniversary! Your dedication, hard work, and positive attitude have truly made a difference. Wishing you continued success and many more milestones ahead!</a:t>
+              <a:t>Happy 1st Work Anniversary, Mathalin! 🎉</a:t>
+            </a:r>
+            <a:br/>
+            <a:r>
+              <a:t>It’s been wonderful seeing your journey over the past year. You have a special way of making the workplace more enjoyable and creating a friendly atmosphere wherever you go. Keep smiling, keep working hard, and keep achieving your goals. Wishing you many more successful years, happiness, and growth in your career.</a:t>
+            </a:r>
+            <a:br/>
+            <a:r>
+              <a:t>Congratulations and best wishes for many more years ahead! 🎊</a:t>
             </a:r>
           </a:p>
         </p:txBody>
@@ -10088,7 +10101,7 @@
         </p:nvSpPr>
         <p:spPr>
           <a:xfrm>
-            <a:off x="2743200" y="2560320"/>
+            <a:off x="2743200" y="3383280"/>
             <a:ext cx="4572000" cy="548640"/>
           </a:xfrm>
           <a:prstGeom prst="rect">
@@ -10112,7 +10125,7 @@
               </a:defRPr>
             </a:pPr>
             <a:r>
-              <a:t>- Sangeetha Samuel</a:t>
+              <a:t>- Mercy</a:t>
             </a:r>
           </a:p>
         </p:txBody>
@@ -10164,7 +10177,7 @@
               </a:defRPr>
             </a:pPr>
             <a:r>
-              <a:t>Congrats on your work anniversary, Karthi Bro! I hope the coming year brings more good work and steady progress.</a:t>
+              <a:t>Happy 1st Work Anniversary, Mathali! Wishing you continued success, growth, and many more achievements ahead.</a:t>
             </a:r>
           </a:p>
         </p:txBody>
@@ -10201,7 +10214,78 @@
               </a:defRPr>
             </a:pPr>
             <a:r>
-              <a:t>- Arumugavel Krishnamoorthi</a:t>
+              <a:t>- Joe</a:t>
+            </a:r>
+          </a:p>
+        </p:txBody>
+      </p:sp>
+      <p:sp>
+        <p:nvSpPr>
+          <p:cNvPr id="4" name="TextBox 3"/>
+          <p:cNvSpPr txBox="1"/>
+          <p:nvPr/>
+        </p:nvSpPr>
+        <p:spPr>
+          <a:xfrm>
+            <a:off x="1828800" y="3017520"/>
+            <a:ext cx="6400800" cy="914400"/>
+          </a:xfrm>
+          <a:prstGeom prst="rect">
+            <a:avLst/>
+          </a:prstGeom>
+          <a:noFill/>
+        </p:spPr>
+        <p:txBody>
+          <a:bodyPr wrap="square">
+            <a:spAutoFit/>
+          </a:bodyPr>
+          <a:lstStyle/>
+          <a:p/>
+          <a:p>
+            <a:pPr algn="l">
+              <a:defRPr sz="1800" b="0" i="0">
+                <a:latin typeface="Times New Roman"/>
+              </a:defRPr>
+            </a:pPr>
+            <a:r>
+              <a:t>Happy 1st Work Anniversary Mathalin! 🎉Congratulations on completing an incredible first year🌟</a:t>
+            </a:r>
+          </a:p>
+        </p:txBody>
+      </p:sp>
+      <p:sp>
+        <p:nvSpPr>
+          <p:cNvPr id="5" name="TextBox 4"/>
+          <p:cNvSpPr txBox="1"/>
+          <p:nvPr/>
+        </p:nvSpPr>
+        <p:spPr>
+          <a:xfrm>
+            <a:off x="2743200" y="3931920"/>
+            <a:ext cx="4572000" cy="548640"/>
+          </a:xfrm>
+          <a:prstGeom prst="rect">
+            <a:avLst/>
+          </a:prstGeom>
+          <a:noFill/>
+        </p:spPr>
+        <p:txBody>
+          <a:bodyPr wrap="square">
+            <a:spAutoFit/>
+          </a:bodyPr>
+          <a:lstStyle/>
+          <a:p/>
+          <a:p>
+            <a:pPr algn="r">
+              <a:defRPr sz="1800" b="1" i="1">
+                <a:solidFill>
+                  <a:srgbClr val="FF0000"/>
+                </a:solidFill>
+                <a:latin typeface="Times New Roman"/>
+              </a:defRPr>
+            </a:pPr>
+            <a:r>
+              <a:t>- Sangeetha</a:t>
             </a:r>
           </a:p>
         </p:txBody>
@@ -10215,6 +10299,530 @@
 </file>
 
 <file path=ppt/slides/slide12.xml><?xml version="1.0" encoding="utf-8"?>
+<p:sld xmlns:a="http://schemas.openxmlformats.org/drawingml/2006/main" xmlns:p="http://schemas.openxmlformats.org/presentationml/2006/main" xmlns:r="http://schemas.openxmlformats.org/officeDocument/2006/relationships">
+  <p:cSld>
+    <p:spTree>
+      <p:nvGrpSpPr>
+        <p:cNvPr id="1" name=""/>
+        <p:cNvGrpSpPr/>
+        <p:nvPr/>
+      </p:nvGrpSpPr>
+      <p:grpSpPr/>
+      <p:sp>
+        <p:nvSpPr>
+          <p:cNvPr id="2" name="TextBox 1"/>
+          <p:cNvSpPr txBox="1"/>
+          <p:nvPr/>
+        </p:nvSpPr>
+        <p:spPr>
+          <a:xfrm>
+            <a:off x="1828800" y="1371600"/>
+            <a:ext cx="6400800" cy="914400"/>
+          </a:xfrm>
+          <a:prstGeom prst="rect">
+            <a:avLst/>
+          </a:prstGeom>
+          <a:noFill/>
+        </p:spPr>
+        <p:txBody>
+          <a:bodyPr wrap="square">
+            <a:spAutoFit/>
+          </a:bodyPr>
+          <a:lstStyle/>
+          <a:p/>
+          <a:p>
+            <a:pPr algn="l">
+              <a:defRPr sz="1800" b="0" i="0">
+                <a:latin typeface="Times New Roman"/>
+              </a:defRPr>
+            </a:pPr>
+            <a:r>
+              <a:t>Happy 1st work anniversary Math !! 🎉🎉Wishing you success, growth and many more milestones to celebrate 🎊 Keep up the great work and continue shining. Best wishes for your journey ahead!</a:t>
+            </a:r>
+          </a:p>
+        </p:txBody>
+      </p:sp>
+      <p:sp>
+        <p:nvSpPr>
+          <p:cNvPr id="3" name="TextBox 2"/>
+          <p:cNvSpPr txBox="1"/>
+          <p:nvPr/>
+        </p:nvSpPr>
+        <p:spPr>
+          <a:xfrm>
+            <a:off x="2743200" y="2560320"/>
+            <a:ext cx="4572000" cy="548640"/>
+          </a:xfrm>
+          <a:prstGeom prst="rect">
+            <a:avLst/>
+          </a:prstGeom>
+          <a:noFill/>
+        </p:spPr>
+        <p:txBody>
+          <a:bodyPr wrap="square">
+            <a:spAutoFit/>
+          </a:bodyPr>
+          <a:lstStyle/>
+          <a:p/>
+          <a:p>
+            <a:pPr algn="r">
+              <a:defRPr sz="1800" b="1" i="1">
+                <a:solidFill>
+                  <a:srgbClr val="FF0000"/>
+                </a:solidFill>
+                <a:latin typeface="Times New Roman"/>
+              </a:defRPr>
+            </a:pPr>
+            <a:r>
+              <a:t>- Saranya</a:t>
+            </a:r>
+          </a:p>
+        </p:txBody>
+      </p:sp>
+    </p:spTree>
+  </p:cSld>
+  <p:clrMapOvr>
+    <a:masterClrMapping/>
+  </p:clrMapOvr>
+</p:sld>
+</file>
+
+<file path=ppt/slides/slide13.xml><?xml version="1.0" encoding="utf-8"?>
+<p:sld xmlns:a="http://schemas.openxmlformats.org/drawingml/2006/main" xmlns:p="http://schemas.openxmlformats.org/presentationml/2006/main" xmlns:r="http://schemas.openxmlformats.org/officeDocument/2006/relationships">
+  <p:cSld>
+    <p:spTree>
+      <p:nvGrpSpPr>
+        <p:cNvPr id="1" name=""/>
+        <p:cNvGrpSpPr/>
+        <p:nvPr/>
+      </p:nvGrpSpPr>
+      <p:grpSpPr/>
+      <p:sp>
+        <p:nvSpPr>
+          <p:cNvPr id="2" name="TextBox 1"/>
+          <p:cNvSpPr txBox="1"/>
+          <p:nvPr/>
+        </p:nvSpPr>
+        <p:spPr>
+          <a:xfrm>
+            <a:off x="1828800" y="1371600"/>
+            <a:ext cx="6400800" cy="914400"/>
+          </a:xfrm>
+          <a:prstGeom prst="rect">
+            <a:avLst/>
+          </a:prstGeom>
+          <a:noFill/>
+        </p:spPr>
+        <p:txBody>
+          <a:bodyPr wrap="square">
+            <a:spAutoFit/>
+          </a:bodyPr>
+          <a:lstStyle/>
+          <a:p/>
+          <a:p>
+            <a:pPr algn="l">
+              <a:defRPr sz="1800" b="0" i="0">
+                <a:latin typeface="Times New Roman"/>
+              </a:defRPr>
+            </a:pPr>
+            <a:r>
+              <a:t>It’s truly special to see you reach this milestone, Mathalin! 🎉 From being my college junior to becoming my colleague at Entrans, it has been wonderful to see your journey and growth. It’s even more special because you’ve always felt like a sister to me.</a:t>
+            </a:r>
+            <a:br/>
+            <a:r>
+              <a:t>Over the past year, you’ve grown, learned, and created wonderful memories along the way. Wishing you continued success, happiness, and countless opportunities in the years ahead. Stay strong, keep smiling, and continue being the wonderful person you are. May this be just the first of many milestones in a bright and rewarding journey. Congratulations on your 1st Entrans Work Anniversary! Math🌟</a:t>
+            </a:r>
+          </a:p>
+        </p:txBody>
+      </p:sp>
+      <p:sp>
+        <p:nvSpPr>
+          <p:cNvPr id="3" name="TextBox 2"/>
+          <p:cNvSpPr txBox="1"/>
+          <p:nvPr/>
+        </p:nvSpPr>
+        <p:spPr>
+          <a:xfrm>
+            <a:off x="2743200" y="4206240"/>
+            <a:ext cx="4572000" cy="548640"/>
+          </a:xfrm>
+          <a:prstGeom prst="rect">
+            <a:avLst/>
+          </a:prstGeom>
+          <a:noFill/>
+        </p:spPr>
+        <p:txBody>
+          <a:bodyPr wrap="square">
+            <a:spAutoFit/>
+          </a:bodyPr>
+          <a:lstStyle/>
+          <a:p/>
+          <a:p>
+            <a:pPr algn="r">
+              <a:defRPr sz="1800" b="1" i="1">
+                <a:solidFill>
+                  <a:srgbClr val="FF0000"/>
+                </a:solidFill>
+                <a:latin typeface="Times New Roman"/>
+              </a:defRPr>
+            </a:pPr>
+            <a:r>
+              <a:t>- Arumugavel</a:t>
+            </a:r>
+          </a:p>
+        </p:txBody>
+      </p:sp>
+    </p:spTree>
+  </p:cSld>
+  <p:clrMapOvr>
+    <a:masterClrMapping/>
+  </p:clrMapOvr>
+</p:sld>
+</file>
+
+<file path=ppt/slides/slide14.xml><?xml version="1.0" encoding="utf-8"?>
+<p:sld xmlns:a="http://schemas.openxmlformats.org/drawingml/2006/main" xmlns:p="http://schemas.openxmlformats.org/presentationml/2006/main" xmlns:r="http://schemas.openxmlformats.org/officeDocument/2006/relationships">
+  <p:cSld>
+    <p:spTree>
+      <p:nvGrpSpPr>
+        <p:cNvPr id="1" name=""/>
+        <p:cNvGrpSpPr/>
+        <p:nvPr/>
+      </p:nvGrpSpPr>
+      <p:grpSpPr/>
+      <p:sp>
+        <p:nvSpPr>
+          <p:cNvPr id="2" name="TextBox 1"/>
+          <p:cNvSpPr txBox="1"/>
+          <p:nvPr/>
+        </p:nvSpPr>
+        <p:spPr>
+          <a:xfrm>
+            <a:off x="1828800" y="1371600"/>
+            <a:ext cx="6400800" cy="914400"/>
+          </a:xfrm>
+          <a:prstGeom prst="rect">
+            <a:avLst/>
+          </a:prstGeom>
+          <a:noFill/>
+        </p:spPr>
+        <p:txBody>
+          <a:bodyPr wrap="square">
+            <a:spAutoFit/>
+          </a:bodyPr>
+          <a:lstStyle/>
+          <a:p/>
+          <a:p>
+            <a:pPr algn="l">
+              <a:defRPr sz="1800" b="0" i="0">
+                <a:latin typeface="Times New Roman"/>
+              </a:defRPr>
+            </a:pPr>
+            <a:r>
+              <a:t>Happy 1st Work Anniversary, Mathalin! Wishing you a fantastic year ahead filled with success and joy.</a:t>
+            </a:r>
+          </a:p>
+        </p:txBody>
+      </p:sp>
+      <p:sp>
+        <p:nvSpPr>
+          <p:cNvPr id="3" name="TextBox 2"/>
+          <p:cNvSpPr txBox="1"/>
+          <p:nvPr/>
+        </p:nvSpPr>
+        <p:spPr>
+          <a:xfrm>
+            <a:off x="2743200" y="2286000"/>
+            <a:ext cx="4572000" cy="548640"/>
+          </a:xfrm>
+          <a:prstGeom prst="rect">
+            <a:avLst/>
+          </a:prstGeom>
+          <a:noFill/>
+        </p:spPr>
+        <p:txBody>
+          <a:bodyPr wrap="square">
+            <a:spAutoFit/>
+          </a:bodyPr>
+          <a:lstStyle/>
+          <a:p/>
+          <a:p>
+            <a:pPr algn="r">
+              <a:defRPr sz="1800" b="1" i="1">
+                <a:solidFill>
+                  <a:srgbClr val="FF0000"/>
+                </a:solidFill>
+                <a:latin typeface="Times New Roman"/>
+              </a:defRPr>
+            </a:pPr>
+            <a:r>
+              <a:t>- Mithun</a:t>
+            </a:r>
+          </a:p>
+        </p:txBody>
+      </p:sp>
+      <p:sp>
+        <p:nvSpPr>
+          <p:cNvPr id="4" name="TextBox 3"/>
+          <p:cNvSpPr txBox="1"/>
+          <p:nvPr/>
+        </p:nvSpPr>
+        <p:spPr>
+          <a:xfrm>
+            <a:off x="1828800" y="3017520"/>
+            <a:ext cx="6400800" cy="914400"/>
+          </a:xfrm>
+          <a:prstGeom prst="rect">
+            <a:avLst/>
+          </a:prstGeom>
+          <a:noFill/>
+        </p:spPr>
+        <p:txBody>
+          <a:bodyPr wrap="square">
+            <a:spAutoFit/>
+          </a:bodyPr>
+          <a:lstStyle/>
+          <a:p/>
+          <a:p>
+            <a:pPr algn="l">
+              <a:defRPr sz="1800" b="0" i="0">
+                <a:latin typeface="Times New Roman"/>
+              </a:defRPr>
+            </a:pPr>
+            <a:r>
+              <a:t>Happy 1st Work Anniversary Mathalin! Wishing you continued success and many more achievements ahead</a:t>
+            </a:r>
+          </a:p>
+        </p:txBody>
+      </p:sp>
+      <p:sp>
+        <p:nvSpPr>
+          <p:cNvPr id="5" name="TextBox 4"/>
+          <p:cNvSpPr txBox="1"/>
+          <p:nvPr/>
+        </p:nvSpPr>
+        <p:spPr>
+          <a:xfrm>
+            <a:off x="2743200" y="3931920"/>
+            <a:ext cx="4572000" cy="548640"/>
+          </a:xfrm>
+          <a:prstGeom prst="rect">
+            <a:avLst/>
+          </a:prstGeom>
+          <a:noFill/>
+        </p:spPr>
+        <p:txBody>
+          <a:bodyPr wrap="square">
+            <a:spAutoFit/>
+          </a:bodyPr>
+          <a:lstStyle/>
+          <a:p/>
+          <a:p>
+            <a:pPr algn="r">
+              <a:defRPr sz="1800" b="1" i="1">
+                <a:solidFill>
+                  <a:srgbClr val="FF0000"/>
+                </a:solidFill>
+                <a:latin typeface="Times New Roman"/>
+              </a:defRPr>
+            </a:pPr>
+            <a:r>
+              <a:t>- Pavithra</a:t>
+            </a:r>
+          </a:p>
+        </p:txBody>
+      </p:sp>
+    </p:spTree>
+  </p:cSld>
+  <p:clrMapOvr>
+    <a:masterClrMapping/>
+  </p:clrMapOvr>
+</p:sld>
+</file>
+
+<file path=ppt/slides/slide15.xml><?xml version="1.0" encoding="utf-8"?>
+<p:sld xmlns:a="http://schemas.openxmlformats.org/drawingml/2006/main" xmlns:p="http://schemas.openxmlformats.org/presentationml/2006/main" xmlns:r="http://schemas.openxmlformats.org/officeDocument/2006/relationships">
+  <p:cSld>
+    <p:spTree>
+      <p:nvGrpSpPr>
+        <p:cNvPr id="1" name=""/>
+        <p:cNvGrpSpPr/>
+        <p:nvPr/>
+      </p:nvGrpSpPr>
+      <p:grpSpPr/>
+      <p:sp>
+        <p:nvSpPr>
+          <p:cNvPr id="2" name="TextBox 1"/>
+          <p:cNvSpPr txBox="1"/>
+          <p:nvPr/>
+        </p:nvSpPr>
+        <p:spPr>
+          <a:xfrm>
+            <a:off x="1828800" y="1371600"/>
+            <a:ext cx="6400800" cy="914400"/>
+          </a:xfrm>
+          <a:prstGeom prst="rect">
+            <a:avLst/>
+          </a:prstGeom>
+          <a:noFill/>
+        </p:spPr>
+        <p:txBody>
+          <a:bodyPr wrap="square">
+            <a:spAutoFit/>
+          </a:bodyPr>
+          <a:lstStyle/>
+          <a:p/>
+          <a:p>
+            <a:pPr algn="l">
+              <a:defRPr sz="1800" b="0" i="0">
+                <a:latin typeface="Times New Roman"/>
+              </a:defRPr>
+            </a:pPr>
+            <a:r>
+              <a:t>Happiee 1st Work Anniversary, Math! 🎉✨</a:t>
+            </a:r>
+            <a:br/>
+            <a:r>
+              <a:t>Your dedication and the positivity you bring every day make a real difference. You have a wonderful way of spreading joy and uplifting everyone around you. We’re truly happy to have you as part of the team. Wishing you many more successful and memorable years ahead! 🌸😊</a:t>
+            </a:r>
+          </a:p>
+        </p:txBody>
+      </p:sp>
+      <p:sp>
+        <p:nvSpPr>
+          <p:cNvPr id="3" name="TextBox 2"/>
+          <p:cNvSpPr txBox="1"/>
+          <p:nvPr/>
+        </p:nvSpPr>
+        <p:spPr>
+          <a:xfrm>
+            <a:off x="2743200" y="2834640"/>
+            <a:ext cx="4572000" cy="548640"/>
+          </a:xfrm>
+          <a:prstGeom prst="rect">
+            <a:avLst/>
+          </a:prstGeom>
+          <a:noFill/>
+        </p:spPr>
+        <p:txBody>
+          <a:bodyPr wrap="square">
+            <a:spAutoFit/>
+          </a:bodyPr>
+          <a:lstStyle/>
+          <a:p/>
+          <a:p>
+            <a:pPr algn="r">
+              <a:defRPr sz="1800" b="1" i="1">
+                <a:solidFill>
+                  <a:srgbClr val="FF0000"/>
+                </a:solidFill>
+                <a:latin typeface="Times New Roman"/>
+              </a:defRPr>
+            </a:pPr>
+            <a:r>
+              <a:t>- Swathisri</a:t>
+            </a:r>
+          </a:p>
+        </p:txBody>
+      </p:sp>
+    </p:spTree>
+  </p:cSld>
+  <p:clrMapOvr>
+    <a:masterClrMapping/>
+  </p:clrMapOvr>
+</p:sld>
+</file>
+
+<file path=ppt/slides/slide16.xml><?xml version="1.0" encoding="utf-8"?>
+<p:sld xmlns:a="http://schemas.openxmlformats.org/drawingml/2006/main" xmlns:p="http://schemas.openxmlformats.org/presentationml/2006/main" xmlns:r="http://schemas.openxmlformats.org/officeDocument/2006/relationships">
+  <p:cSld>
+    <p:spTree>
+      <p:nvGrpSpPr>
+        <p:cNvPr id="1" name=""/>
+        <p:cNvGrpSpPr/>
+        <p:nvPr/>
+      </p:nvGrpSpPr>
+      <p:grpSpPr/>
+      <p:sp>
+        <p:nvSpPr>
+          <p:cNvPr id="2" name="TextBox 1"/>
+          <p:cNvSpPr txBox="1"/>
+          <p:nvPr/>
+        </p:nvSpPr>
+        <p:spPr>
+          <a:xfrm>
+            <a:off x="1828800" y="1371600"/>
+            <a:ext cx="6400800" cy="914400"/>
+          </a:xfrm>
+          <a:prstGeom prst="rect">
+            <a:avLst/>
+          </a:prstGeom>
+          <a:noFill/>
+        </p:spPr>
+        <p:txBody>
+          <a:bodyPr wrap="square">
+            <a:spAutoFit/>
+          </a:bodyPr>
+          <a:lstStyle/>
+          <a:p/>
+          <a:p>
+            <a:pPr algn="l">
+              <a:defRPr sz="1800" b="0" i="0">
+                <a:latin typeface="Times New Roman"/>
+              </a:defRPr>
+            </a:pPr>
+            <a:r>
+              <a:t>Happy 1st Work Anniversary, Mathali! Wishing you continued success, growth, and many more achievements ahead.</a:t>
+            </a:r>
+          </a:p>
+        </p:txBody>
+      </p:sp>
+      <p:sp>
+        <p:nvSpPr>
+          <p:cNvPr id="3" name="TextBox 2"/>
+          <p:cNvSpPr txBox="1"/>
+          <p:nvPr/>
+        </p:nvSpPr>
+        <p:spPr>
+          <a:xfrm>
+            <a:off x="2743200" y="2286000"/>
+            <a:ext cx="4572000" cy="548640"/>
+          </a:xfrm>
+          <a:prstGeom prst="rect">
+            <a:avLst/>
+          </a:prstGeom>
+          <a:noFill/>
+        </p:spPr>
+        <p:txBody>
+          <a:bodyPr wrap="square">
+            <a:spAutoFit/>
+          </a:bodyPr>
+          <a:lstStyle/>
+          <a:p/>
+          <a:p>
+            <a:pPr algn="r">
+              <a:defRPr sz="1800" b="1" i="1">
+                <a:solidFill>
+                  <a:srgbClr val="FF0000"/>
+                </a:solidFill>
+                <a:latin typeface="Times New Roman"/>
+              </a:defRPr>
+            </a:pPr>
+            <a:r>
+              <a:t>- John</a:t>
+            </a:r>
+          </a:p>
+        </p:txBody>
+      </p:sp>
+    </p:spTree>
+  </p:cSld>
+  <p:clrMapOvr>
+    <a:masterClrMapping/>
+  </p:clrMapOvr>
+</p:sld>
+</file>
+
+<file path=ppt/slides/slide17.xml><?xml version="1.0" encoding="utf-8"?>
 <p:sld xmlns:a="http://schemas.openxmlformats.org/drawingml/2006/main" xmlns:p="http://schemas.openxmlformats.org/presentationml/2006/main" xmlns:r="http://schemas.openxmlformats.org/officeDocument/2006/relationships">
   <p:cSld>
     <p:spTree>
@@ -12284,7 +12892,7 @@
               </a:defRPr>
             </a:pPr>
             <a:r>
-              <a:t>Congrats for your 1st work anniversary in Entrans</a:t>
+              <a:t>Happy 1st work anniversary Mathalin! Wishing you many more successful years ahead.</a:t>
             </a:r>
           </a:p>
         </p:txBody>
@@ -12297,7 +12905,7 @@
         </p:nvSpPr>
         <p:spPr>
           <a:xfrm>
-            <a:off x="2743200" y="1828800"/>
+            <a:off x="2743200" y="2286000"/>
             <a:ext cx="4572000" cy="548640"/>
           </a:xfrm>
           <a:prstGeom prst="rect">
@@ -12321,7 +12929,7 @@
               </a:defRPr>
             </a:pPr>
             <a:r>
-              <a:t>- Krishnaraj Rajagopal</a:t>
+              <a:t>- Rufus</a:t>
             </a:r>
           </a:p>
         </p:txBody>
@@ -12373,7 +12981,11 @@
               </a:defRPr>
             </a:pPr>
             <a:r>
-              <a:t>Congratulations on your first work anniversary! Wishing you continued success and growth. You’ve been doing an amazing job — keep rocking</a:t>
+              <a:t>🎉 Happy 1st Work Anniversary, Mathalin! 🎉</a:t>
+            </a:r>
+            <a:br/>
+            <a:r>
+              <a:t>It's amazing to see how much you've grown and achieved in one year. Your hard work, dedication, and positive attitude are truly inspiring. Wishing you many more successful years ahead filled with happiness, growth, and achievements. 🌟</a:t>
             </a:r>
           </a:p>
         </p:txBody>
@@ -12386,7 +12998,7 @@
         </p:nvSpPr>
         <p:spPr>
           <a:xfrm>
-            <a:off x="2743200" y="2286000"/>
+            <a:off x="2743200" y="2834640"/>
             <a:ext cx="4572000" cy="548640"/>
           </a:xfrm>
           <a:prstGeom prst="rect">
@@ -12410,7 +13022,7 @@
               </a:defRPr>
             </a:pPr>
             <a:r>
-              <a:t>- Prabakaran Subramani</a:t>
+              <a:t>- Nagalakshmi</a:t>
             </a:r>
           </a:p>
         </p:txBody>
@@ -12462,7 +13074,7 @@
               </a:defRPr>
             </a:pPr>
             <a:r>
-              <a:t>One year down, many more to go! Your hard work and dedication are truly appreciated</a:t>
+              <a:t>Congratulations on completing one year math akka! It's wonderful to see your hard work, dedication, and growth over the past year. Your positive attitude and the joy you spread make a difference to everyone around you. Wishing you continued success, happiness, and many more achievements in the years ahead</a:t>
             </a:r>
           </a:p>
         </p:txBody>
@@ -12475,7 +13087,7 @@
         </p:nvSpPr>
         <p:spPr>
           <a:xfrm>
-            <a:off x="2743200" y="2286000"/>
+            <a:off x="2743200" y="2834640"/>
             <a:ext cx="4572000" cy="548640"/>
           </a:xfrm>
           <a:prstGeom prst="rect">
@@ -12499,78 +13111,7 @@
               </a:defRPr>
             </a:pPr>
             <a:r>
-              <a:t>- Dilipkumar Selvaraj</a:t>
-            </a:r>
-          </a:p>
-        </p:txBody>
-      </p:sp>
-      <p:sp>
-        <p:nvSpPr>
-          <p:cNvPr id="4" name="TextBox 3"/>
-          <p:cNvSpPr txBox="1"/>
-          <p:nvPr/>
-        </p:nvSpPr>
-        <p:spPr>
-          <a:xfrm>
-            <a:off x="1828800" y="3017520"/>
-            <a:ext cx="6400800" cy="914400"/>
-          </a:xfrm>
-          <a:prstGeom prst="rect">
-            <a:avLst/>
-          </a:prstGeom>
-          <a:noFill/>
-        </p:spPr>
-        <p:txBody>
-          <a:bodyPr wrap="square">
-            <a:spAutoFit/>
-          </a:bodyPr>
-          <a:lstStyle/>
-          <a:p/>
-          <a:p>
-            <a:pPr algn="l">
-              <a:defRPr sz="1800" b="0" i="0">
-                <a:latin typeface="Times New Roman"/>
-              </a:defRPr>
-            </a:pPr>
-            <a:r>
-              <a:t>Congrats for your first anniversary</a:t>
-            </a:r>
-          </a:p>
-        </p:txBody>
-      </p:sp>
-      <p:sp>
-        <p:nvSpPr>
-          <p:cNvPr id="5" name="TextBox 4"/>
-          <p:cNvSpPr txBox="1"/>
-          <p:nvPr/>
-        </p:nvSpPr>
-        <p:spPr>
-          <a:xfrm>
-            <a:off x="2743200" y="3474720"/>
-            <a:ext cx="4572000" cy="548640"/>
-          </a:xfrm>
-          <a:prstGeom prst="rect">
-            <a:avLst/>
-          </a:prstGeom>
-          <a:noFill/>
-        </p:spPr>
-        <p:txBody>
-          <a:bodyPr wrap="square">
-            <a:spAutoFit/>
-          </a:bodyPr>
-          <a:lstStyle/>
-          <a:p/>
-          <a:p>
-            <a:pPr algn="r">
-              <a:defRPr sz="1800" b="1" i="1">
-                <a:solidFill>
-                  <a:srgbClr val="FF0000"/>
-                </a:solidFill>
-                <a:latin typeface="Times New Roman"/>
-              </a:defRPr>
-            </a:pPr>
-            <a:r>
-              <a:t>- Prasath Govindaraj</a:t>
+              <a:t>- Angel</a:t>
             </a:r>
           </a:p>
         </p:txBody>

</xml_diff>

<commit_message>
feat: implement project member management, timesheet reminder functionality, and associated backend API support
</commit_message>
<xml_diff>
--- a/entrans-hr-hub-backend/myproject/media/Final_Anniversary_Presentation.pptx
+++ b/entrans-hr-hub-backend/myproject/media/Final_Anniversary_Presentation.pptx
@@ -10028,7 +10028,7 @@
               </a:defRPr>
             </a:pPr>
             <a:r>
-              <a:t>Joe Dharsic</a:t>
+              <a:t>Joe</a:t>
             </a:r>
           </a:p>
         </p:txBody>
@@ -10080,15 +10080,7 @@
               </a:defRPr>
             </a:pPr>
             <a:r>
-              <a:t>Happy 1st Work Anniversary, Mathalin! 🎉</a:t>
-            </a:r>
-            <a:br/>
-            <a:r>
-              <a:t>It’s been wonderful seeing your journey over the past year. You have a special way of making the workplace more enjoyable and creating a friendly atmosphere wherever you go. Keep smiling, keep working hard, and keep achieving your goals. Wishing you many more successful years, happiness, and growth in your career.</a:t>
-            </a:r>
-            <a:br/>
-            <a:r>
-              <a:t>Congratulations and best wishes for many more years ahead! 🎊</a:t>
+              <a:t>Happy 6th Work Anniversary! Your experience, leadership, and dedication continue to inspire us. Wishing you continued success and many more remarkable milestones ahead.</a:t>
             </a:r>
           </a:p>
         </p:txBody>
@@ -10101,7 +10093,7 @@
         </p:nvSpPr>
         <p:spPr>
           <a:xfrm>
-            <a:off x="2743200" y="3383280"/>
+            <a:off x="2743200" y="2560320"/>
             <a:ext cx="4572000" cy="548640"/>
           </a:xfrm>
           <a:prstGeom prst="rect">
@@ -10125,7 +10117,7 @@
               </a:defRPr>
             </a:pPr>
             <a:r>
-              <a:t>- Mercy</a:t>
+              <a:t>- Elamaran Karuppaiya</a:t>
             </a:r>
           </a:p>
         </p:txBody>
@@ -10177,7 +10169,7 @@
               </a:defRPr>
             </a:pPr>
             <a:r>
-              <a:t>Happy 1st Work Anniversary, Mathali! Wishing you continued success, growth, and many more achievements ahead.</a:t>
+              <a:t>Happy 6th Work Anniversary, kulanthai sir! Congratulations on this wonderful milestone! Thank you for being such a supportive and dependable. Wishing you continued success and happiness in the years ahead!</a:t>
             </a:r>
           </a:p>
         </p:txBody>
@@ -10190,7 +10182,7 @@
         </p:nvSpPr>
         <p:spPr>
           <a:xfrm>
-            <a:off x="2743200" y="2286000"/>
+            <a:off x="2743200" y="2560320"/>
             <a:ext cx="4572000" cy="548640"/>
           </a:xfrm>
           <a:prstGeom prst="rect">
@@ -10214,78 +10206,7 @@
               </a:defRPr>
             </a:pPr>
             <a:r>
-              <a:t>- Joe</a:t>
-            </a:r>
-          </a:p>
-        </p:txBody>
-      </p:sp>
-      <p:sp>
-        <p:nvSpPr>
-          <p:cNvPr id="4" name="TextBox 3"/>
-          <p:cNvSpPr txBox="1"/>
-          <p:nvPr/>
-        </p:nvSpPr>
-        <p:spPr>
-          <a:xfrm>
-            <a:off x="1828800" y="3017520"/>
-            <a:ext cx="6400800" cy="914400"/>
-          </a:xfrm>
-          <a:prstGeom prst="rect">
-            <a:avLst/>
-          </a:prstGeom>
-          <a:noFill/>
-        </p:spPr>
-        <p:txBody>
-          <a:bodyPr wrap="square">
-            <a:spAutoFit/>
-          </a:bodyPr>
-          <a:lstStyle/>
-          <a:p/>
-          <a:p>
-            <a:pPr algn="l">
-              <a:defRPr sz="1800" b="0" i="0">
-                <a:latin typeface="Times New Roman"/>
-              </a:defRPr>
-            </a:pPr>
-            <a:r>
-              <a:t>Happy 1st Work Anniversary Mathalin! 🎉Congratulations on completing an incredible first year🌟</a:t>
-            </a:r>
-          </a:p>
-        </p:txBody>
-      </p:sp>
-      <p:sp>
-        <p:nvSpPr>
-          <p:cNvPr id="5" name="TextBox 4"/>
-          <p:cNvSpPr txBox="1"/>
-          <p:nvPr/>
-        </p:nvSpPr>
-        <p:spPr>
-          <a:xfrm>
-            <a:off x="2743200" y="3931920"/>
-            <a:ext cx="4572000" cy="548640"/>
-          </a:xfrm>
-          <a:prstGeom prst="rect">
-            <a:avLst/>
-          </a:prstGeom>
-          <a:noFill/>
-        </p:spPr>
-        <p:txBody>
-          <a:bodyPr wrap="square">
-            <a:spAutoFit/>
-          </a:bodyPr>
-          <a:lstStyle/>
-          <a:p/>
-          <a:p>
-            <a:pPr algn="r">
-              <a:defRPr sz="1800" b="1" i="1">
-                <a:solidFill>
-                  <a:srgbClr val="FF0000"/>
-                </a:solidFill>
-                <a:latin typeface="Times New Roman"/>
-              </a:defRPr>
-            </a:pPr>
-            <a:r>
-              <a:t>- Sangeetha</a:t>
+              <a:t>- Vengadesan Karuppaiyan</a:t>
             </a:r>
           </a:p>
         </p:txBody>
@@ -10337,7 +10258,7 @@
               </a:defRPr>
             </a:pPr>
             <a:r>
-              <a:t>Happy 1st work anniversary Math !! 🎉🎉Wishing you success, growth and many more milestones to celebrate 🎊 Keep up the great work and continue shining. Best wishes for your journey ahead!</a:t>
+              <a:t>Congratulations on your 6th Work Anniversary bro! Wishing you continued success, good health, and many more milestones. Keep up the great work!</a:t>
             </a:r>
           </a:p>
         </p:txBody>
@@ -10350,7 +10271,7 @@
         </p:nvSpPr>
         <p:spPr>
           <a:xfrm>
-            <a:off x="2743200" y="2560320"/>
+            <a:off x="2743200" y="2286000"/>
             <a:ext cx="4572000" cy="548640"/>
           </a:xfrm>
           <a:prstGeom prst="rect">
@@ -10374,7 +10295,7 @@
               </a:defRPr>
             </a:pPr>
             <a:r>
-              <a:t>- Saranya</a:t>
+              <a:t>- Rufus</a:t>
             </a:r>
           </a:p>
         </p:txBody>
@@ -10426,11 +10347,7 @@
               </a:defRPr>
             </a:pPr>
             <a:r>
-              <a:t>It’s truly special to see you reach this milestone, Mathalin! 🎉 From being my college junior to becoming my colleague at Entrans, it has been wonderful to see your journey and growth. It’s even more special because you’ve always felt like a sister to me.</a:t>
-            </a:r>
-            <a:br/>
-            <a:r>
-              <a:t>Over the past year, you’ve grown, learned, and created wonderful memories along the way. Wishing you continued success, happiness, and countless opportunities in the years ahead. Stay strong, keep smiling, and continue being the wonderful person you are. May this be just the first of many milestones in a bright and rewarding journey. Congratulations on your 1st Entrans Work Anniversary! Math🌟</a:t>
+              <a:t>Happy Work Anniversary, Anna!. Wishing you an even more exciting journey ahead!🎉 🎉</a:t>
             </a:r>
           </a:p>
         </p:txBody>
@@ -10443,7 +10360,7 @@
         </p:nvSpPr>
         <p:spPr>
           <a:xfrm>
-            <a:off x="2743200" y="4206240"/>
+            <a:off x="2743200" y="2286000"/>
             <a:ext cx="4572000" cy="548640"/>
           </a:xfrm>
           <a:prstGeom prst="rect">
@@ -10467,7 +10384,7 @@
               </a:defRPr>
             </a:pPr>
             <a:r>
-              <a:t>- Arumugavel</a:t>
+              <a:t>- Sriman Kumarasami</a:t>
             </a:r>
           </a:p>
         </p:txBody>
@@ -10519,7 +10436,7 @@
               </a:defRPr>
             </a:pPr>
             <a:r>
-              <a:t>Happy 1st Work Anniversary, Mathalin! Wishing you a fantastic year ahead filled with success and joy.</a:t>
+              <a:t>Happy Work Anniversary Anna! Wishing you continued success, growth, and many more achievements in the years ahead. Congratulations on this milestone!</a:t>
             </a:r>
           </a:p>
         </p:txBody>
@@ -10556,78 +10473,7 @@
               </a:defRPr>
             </a:pPr>
             <a:r>
-              <a:t>- Mithun</a:t>
-            </a:r>
-          </a:p>
-        </p:txBody>
-      </p:sp>
-      <p:sp>
-        <p:nvSpPr>
-          <p:cNvPr id="4" name="TextBox 3"/>
-          <p:cNvSpPr txBox="1"/>
-          <p:nvPr/>
-        </p:nvSpPr>
-        <p:spPr>
-          <a:xfrm>
-            <a:off x="1828800" y="3017520"/>
-            <a:ext cx="6400800" cy="914400"/>
-          </a:xfrm>
-          <a:prstGeom prst="rect">
-            <a:avLst/>
-          </a:prstGeom>
-          <a:noFill/>
-        </p:spPr>
-        <p:txBody>
-          <a:bodyPr wrap="square">
-            <a:spAutoFit/>
-          </a:bodyPr>
-          <a:lstStyle/>
-          <a:p/>
-          <a:p>
-            <a:pPr algn="l">
-              <a:defRPr sz="1800" b="0" i="0">
-                <a:latin typeface="Times New Roman"/>
-              </a:defRPr>
-            </a:pPr>
-            <a:r>
-              <a:t>Happy 1st Work Anniversary Mathalin! Wishing you continued success and many more achievements ahead</a:t>
-            </a:r>
-          </a:p>
-        </p:txBody>
-      </p:sp>
-      <p:sp>
-        <p:nvSpPr>
-          <p:cNvPr id="5" name="TextBox 4"/>
-          <p:cNvSpPr txBox="1"/>
-          <p:nvPr/>
-        </p:nvSpPr>
-        <p:spPr>
-          <a:xfrm>
-            <a:off x="2743200" y="3931920"/>
-            <a:ext cx="4572000" cy="548640"/>
-          </a:xfrm>
-          <a:prstGeom prst="rect">
-            <a:avLst/>
-          </a:prstGeom>
-          <a:noFill/>
-        </p:spPr>
-        <p:txBody>
-          <a:bodyPr wrap="square">
-            <a:spAutoFit/>
-          </a:bodyPr>
-          <a:lstStyle/>
-          <a:p/>
-          <a:p>
-            <a:pPr algn="r">
-              <a:defRPr sz="1800" b="1" i="1">
-                <a:solidFill>
-                  <a:srgbClr val="FF0000"/>
-                </a:solidFill>
-                <a:latin typeface="Times New Roman"/>
-              </a:defRPr>
-            </a:pPr>
-            <a:r>
-              <a:t>- Pavithra</a:t>
+              <a:t>- Pavithra Venkatesan</a:t>
             </a:r>
           </a:p>
         </p:txBody>
@@ -10679,11 +10525,7 @@
               </a:defRPr>
             </a:pPr>
             <a:r>
-              <a:t>Happiee 1st Work Anniversary, Math! 🎉✨</a:t>
-            </a:r>
-            <a:br/>
-            <a:r>
-              <a:t>Your dedication and the positivity you bring every day make a real difference. You have a wonderful way of spreading joy and uplifting everyone around you. We’re truly happy to have you as part of the team. Wishing you many more successful and memorable years ahead! 🌸😊</a:t>
+              <a:t>Congratulations on six successful years with Entrans!</a:t>
             </a:r>
           </a:p>
         </p:txBody>
@@ -10696,7 +10538,7 @@
         </p:nvSpPr>
         <p:spPr>
           <a:xfrm>
-            <a:off x="2743200" y="2834640"/>
+            <a:off x="2743200" y="1828800"/>
             <a:ext cx="4572000" cy="548640"/>
           </a:xfrm>
           <a:prstGeom prst="rect">
@@ -10720,7 +10562,78 @@
               </a:defRPr>
             </a:pPr>
             <a:r>
-              <a:t>- Swathisri</a:t>
+              <a:t>- Joe Dharsic Devadhas Jeba Pandian</a:t>
+            </a:r>
+          </a:p>
+        </p:txBody>
+      </p:sp>
+      <p:sp>
+        <p:nvSpPr>
+          <p:cNvPr id="4" name="TextBox 3"/>
+          <p:cNvSpPr txBox="1"/>
+          <p:nvPr/>
+        </p:nvSpPr>
+        <p:spPr>
+          <a:xfrm>
+            <a:off x="1828800" y="2560320"/>
+            <a:ext cx="6400800" cy="914400"/>
+          </a:xfrm>
+          <a:prstGeom prst="rect">
+            <a:avLst/>
+          </a:prstGeom>
+          <a:noFill/>
+        </p:spPr>
+        <p:txBody>
+          <a:bodyPr wrap="square">
+            <a:spAutoFit/>
+          </a:bodyPr>
+          <a:lstStyle/>
+          <a:p/>
+          <a:p>
+            <a:pPr algn="l">
+              <a:defRPr sz="1800" b="0" i="0">
+                <a:latin typeface="Times New Roman"/>
+              </a:defRPr>
+            </a:pPr>
+            <a:r>
+              <a:t>Happy workiversary anna</a:t>
+            </a:r>
+          </a:p>
+        </p:txBody>
+      </p:sp>
+      <p:sp>
+        <p:nvSpPr>
+          <p:cNvPr id="5" name="TextBox 4"/>
+          <p:cNvSpPr txBox="1"/>
+          <p:nvPr/>
+        </p:nvSpPr>
+        <p:spPr>
+          <a:xfrm>
+            <a:off x="2743200" y="3017520"/>
+            <a:ext cx="4572000" cy="548640"/>
+          </a:xfrm>
+          <a:prstGeom prst="rect">
+            <a:avLst/>
+          </a:prstGeom>
+          <a:noFill/>
+        </p:spPr>
+        <p:txBody>
+          <a:bodyPr wrap="square">
+            <a:spAutoFit/>
+          </a:bodyPr>
+          <a:lstStyle/>
+          <a:p/>
+          <a:p>
+            <a:pPr algn="r">
+              <a:defRPr sz="1800" b="1" i="1">
+                <a:solidFill>
+                  <a:srgbClr val="FF0000"/>
+                </a:solidFill>
+                <a:latin typeface="Times New Roman"/>
+              </a:defRPr>
+            </a:pPr>
+            <a:r>
+              <a:t>- Gavaskar</a:t>
             </a:r>
           </a:p>
         </p:txBody>
@@ -10772,7 +10685,7 @@
               </a:defRPr>
             </a:pPr>
             <a:r>
-              <a:t>Happy 1st Work Anniversary, Mathali! Wishing you continued success, growth, and many more achievements ahead.</a:t>
+              <a:t>Happy Work Anniversary Anna. Your loyalty, knowledge, and steady presence are the cornerstone of our success. Wishing you continued growth and happiness in your career.</a:t>
             </a:r>
           </a:p>
         </p:txBody>
@@ -10785,7 +10698,7 @@
         </p:nvSpPr>
         <p:spPr>
           <a:xfrm>
-            <a:off x="2743200" y="2286000"/>
+            <a:off x="2743200" y="2560320"/>
             <a:ext cx="4572000" cy="548640"/>
           </a:xfrm>
           <a:prstGeom prst="rect">
@@ -10809,7 +10722,7 @@
               </a:defRPr>
             </a:pPr>
             <a:r>
-              <a:t>- John</a:t>
+              <a:t>- Kalimuthu</a:t>
             </a:r>
           </a:p>
         </p:txBody>
@@ -12892,7 +12805,7 @@
               </a:defRPr>
             </a:pPr>
             <a:r>
-              <a:t>Happy 1st work anniversary Mathalin! Wishing you many more successful years ahead.</a:t>
+              <a:t>Happy 6th Work Anniversary, Kulanthai Sir! 🎉 Wishing you continued success and many more milestones ahead. It's been a privilege working with you from the very beginning. Congratulations and best wishes always!</a:t>
             </a:r>
           </a:p>
         </p:txBody>
@@ -12905,7 +12818,7 @@
         </p:nvSpPr>
         <p:spPr>
           <a:xfrm>
-            <a:off x="2743200" y="2286000"/>
+            <a:off x="2743200" y="2560320"/>
             <a:ext cx="4572000" cy="548640"/>
           </a:xfrm>
           <a:prstGeom prst="rect">
@@ -12929,7 +12842,7 @@
               </a:defRPr>
             </a:pPr>
             <a:r>
-              <a:t>- Rufus</a:t>
+              <a:t>- Jebastin Gnanadurai Ussia Raja</a:t>
             </a:r>
           </a:p>
         </p:txBody>
@@ -12981,11 +12894,7 @@
               </a:defRPr>
             </a:pPr>
             <a:r>
-              <a:t>🎉 Happy 1st Work Anniversary, Mathalin! 🎉</a:t>
-            </a:r>
-            <a:br/>
-            <a:r>
-              <a:t>It's amazing to see how much you've grown and achieved in one year. Your hard work, dedication, and positive attitude are truly inspiring. Wishing you many more successful years ahead filled with happiness, growth, and achievements. 🌟</a:t>
+              <a:t>Congratulations on completing 6 amazing years with the Entrans!</a:t>
             </a:r>
           </a:p>
         </p:txBody>
@@ -12998,7 +12907,7 @@
         </p:nvSpPr>
         <p:spPr>
           <a:xfrm>
-            <a:off x="2743200" y="2834640"/>
+            <a:off x="2743200" y="1828800"/>
             <a:ext cx="4572000" cy="548640"/>
           </a:xfrm>
           <a:prstGeom prst="rect">
@@ -13022,7 +12931,78 @@
               </a:defRPr>
             </a:pPr>
             <a:r>
-              <a:t>- Nagalakshmi</a:t>
+              <a:t>- Anand  Ramasamy</a:t>
+            </a:r>
+          </a:p>
+        </p:txBody>
+      </p:sp>
+      <p:sp>
+        <p:nvSpPr>
+          <p:cNvPr id="4" name="TextBox 3"/>
+          <p:cNvSpPr txBox="1"/>
+          <p:nvPr/>
+        </p:nvSpPr>
+        <p:spPr>
+          <a:xfrm>
+            <a:off x="1828800" y="2560320"/>
+            <a:ext cx="6400800" cy="914400"/>
+          </a:xfrm>
+          <a:prstGeom prst="rect">
+            <a:avLst/>
+          </a:prstGeom>
+          <a:noFill/>
+        </p:spPr>
+        <p:txBody>
+          <a:bodyPr wrap="square">
+            <a:spAutoFit/>
+          </a:bodyPr>
+          <a:lstStyle/>
+          <a:p/>
+          <a:p>
+            <a:pPr algn="l">
+              <a:defRPr sz="1800" b="0" i="0">
+                <a:latin typeface="Times New Roman"/>
+              </a:defRPr>
+            </a:pPr>
+            <a:r>
+              <a:t>Happy Work Anniversary.  Wishing you an even more exciting journey ahead!🎉 🎉</a:t>
+            </a:r>
+          </a:p>
+        </p:txBody>
+      </p:sp>
+      <p:sp>
+        <p:nvSpPr>
+          <p:cNvPr id="5" name="TextBox 4"/>
+          <p:cNvSpPr txBox="1"/>
+          <p:nvPr/>
+        </p:nvSpPr>
+        <p:spPr>
+          <a:xfrm>
+            <a:off x="2743200" y="3017520"/>
+            <a:ext cx="4572000" cy="548640"/>
+          </a:xfrm>
+          <a:prstGeom prst="rect">
+            <a:avLst/>
+          </a:prstGeom>
+          <a:noFill/>
+        </p:spPr>
+        <p:txBody>
+          <a:bodyPr wrap="square">
+            <a:spAutoFit/>
+          </a:bodyPr>
+          <a:lstStyle/>
+          <a:p/>
+          <a:p>
+            <a:pPr algn="r">
+              <a:defRPr sz="1800" b="1" i="1">
+                <a:solidFill>
+                  <a:srgbClr val="FF0000"/>
+                </a:solidFill>
+                <a:latin typeface="Times New Roman"/>
+              </a:defRPr>
+            </a:pPr>
+            <a:r>
+              <a:t>- Chenthil Murugan</a:t>
             </a:r>
           </a:p>
         </p:txBody>
@@ -13074,7 +13054,7 @@
               </a:defRPr>
             </a:pPr>
             <a:r>
-              <a:t>Congratulations on completing one year math akka! It's wonderful to see your hard work, dedication, and growth over the past year. Your positive attitude and the joy you spread make a difference to everyone around you. Wishing you continued success, happiness, and many more achievements in the years ahead</a:t>
+              <a:t>Happy work anniversary! 🎉 Wishing you continued success and growth ahead.</a:t>
             </a:r>
           </a:p>
         </p:txBody>
@@ -13087,7 +13067,7 @@
         </p:nvSpPr>
         <p:spPr>
           <a:xfrm>
-            <a:off x="2743200" y="2834640"/>
+            <a:off x="2743200" y="1828800"/>
             <a:ext cx="4572000" cy="548640"/>
           </a:xfrm>
           <a:prstGeom prst="rect">
@@ -13111,7 +13091,7 @@
               </a:defRPr>
             </a:pPr>
             <a:r>
-              <a:t>- Angel</a:t>
+              <a:t>- Sachin Issac Koilraj</a:t>
             </a:r>
           </a:p>
         </p:txBody>

</xml_diff>